<commit_message>
Add Martins Nwanu to team pitch and submission materials.
Two-founder team slide in judge and investor decks; SUBMISSION section 1 updated with Creditville IT leadership credentials.
</commit_message>
<xml_diff>
--- a/docs/Credara_Investor_Deck.pptx
+++ b/docs/Credara_Investor_Deck.pptx
@@ -3272,7 +3272,7 @@
               </a:defRPr>
             </a:pPr>
             <a:r>
-              <a:t>Othniel Obasi · NOVTIA Ltd · credara-jet.vercel.app</a:t>
+              <a:t>Othniel Obasi &amp; Martins Nwanu · NOVTIA Ltd · credara-jet.vercel.app</a:t>
             </a:r>
           </a:p>
         </p:txBody>
@@ -4288,7 +4288,7 @@
               </a:defRPr>
             </a:pPr>
             <a:r>
-              <a:t>Operator-founder with regulated-scale delivery track record</a:t>
+              <a:t>Founder + banking engineering leadership — regulated delivery at scale</a:t>
             </a:r>
           </a:p>
         </p:txBody>
@@ -4457,8 +4457,43 @@
         </p:nvSpPr>
         <p:spPr>
           <a:xfrm>
-            <a:off x="822960" y="2011680"/>
-            <a:ext cx="10515600" cy="3474720"/>
+            <a:off x="822960" y="1874519"/>
+            <a:ext cx="5120640" cy="365760"/>
+          </a:xfrm>
+          <a:prstGeom prst="rect">
+            <a:avLst/>
+          </a:prstGeom>
+          <a:noFill/>
+        </p:spPr>
+        <p:txBody>
+          <a:bodyPr wrap="square">
+            <a:spAutoFit/>
+          </a:bodyPr>
+          <a:lstStyle/>
+          <a:p>
+            <a:pPr algn="l">
+              <a:defRPr sz="1400" b="1">
+                <a:solidFill>
+                  <a:srgbClr val="2563EB"/>
+                </a:solidFill>
+              </a:defRPr>
+            </a:pPr>
+            <a:r>
+              <a:t>Othniel Obasi — Founder, NOVTIA Ltd (London)</a:t>
+            </a:r>
+          </a:p>
+        </p:txBody>
+      </p:sp>
+      <p:sp>
+        <p:nvSpPr>
+          <p:cNvPr id="9" name="TextBox 8"/>
+          <p:cNvSpPr txBox="1"/>
+          <p:nvPr/>
+        </p:nvSpPr>
+        <p:spPr>
+          <a:xfrm>
+            <a:off x="822960" y="2240280"/>
+            <a:ext cx="5120640" cy="3200400"/>
           </a:xfrm>
           <a:prstGeom prst="rect">
             <a:avLst/>
@@ -4473,83 +4508,229 @@
           <a:p>
             <a:pPr>
               <a:spcAft>
-                <a:spcPts val="684"/>
+                <a:spcPts val="603"/>
               </a:spcAft>
-              <a:defRPr sz="1700">
+              <a:defRPr sz="1500">
                 <a:solidFill>
                   <a:srgbClr val="111827"/>
                 </a:solidFill>
               </a:defRPr>
             </a:pPr>
             <a:r>
-              <a:t>Othniel Obasi — Founder, NOVTIA Ltd (London)</a:t>
+              <a:t>Creditville MFBank 40K → 100K+ users</a:t>
             </a:r>
           </a:p>
           <a:p>
             <a:pPr>
               <a:spcAft>
-                <a:spcPts val="684"/>
+                <a:spcPts val="603"/>
               </a:spcAft>
-              <a:defRPr sz="1700">
+              <a:defRPr sz="1500">
                 <a:solidFill>
                   <a:srgbClr val="111827"/>
                 </a:solidFill>
               </a:defRPr>
             </a:pPr>
             <a:r>
-              <a:t>Digital banking: Creditville MFBank 40K → 100K+ users</a:t>
+              <a:t>PHED utilities — 5M+ customers, $96M+ revenue growth</a:t>
             </a:r>
           </a:p>
           <a:p>
             <a:pPr>
               <a:spcAft>
-                <a:spcPts val="684"/>
+                <a:spcPts val="603"/>
               </a:spcAft>
-              <a:defRPr sz="1700">
+              <a:defRPr sz="1500">
                 <a:solidFill>
                   <a:srgbClr val="111827"/>
                 </a:solidFill>
               </a:defRPr>
             </a:pPr>
             <a:r>
-              <a:t>Utilities: PHED transformation — 5M+ customers, $96M+ revenue growth</a:t>
+              <a:t>AIRG + SURGE v2 → Credara evidence model</a:t>
             </a:r>
           </a:p>
           <a:p>
             <a:pPr>
               <a:spcAft>
-                <a:spcPts val="684"/>
+                <a:spcPts val="603"/>
               </a:spcAft>
-              <a:defRPr sz="1700">
+              <a:defRPr sz="1500">
                 <a:solidFill>
                   <a:srgbClr val="111827"/>
                 </a:solidFill>
               </a:defRPr>
             </a:pPr>
             <a:r>
-              <a:t>AI governance: AIRG + SURGE v2 cryptographic receipt chain → Credara evidence model</a:t>
-            </a:r>
-          </a:p>
+              <a:t>Portfolio: NorthBridge, Kairos, ProofSource, Autonix</a:t>
+            </a:r>
+          </a:p>
+        </p:txBody>
+      </p:sp>
+      <p:sp>
+        <p:nvSpPr>
+          <p:cNvPr id="10" name="TextBox 9"/>
+          <p:cNvSpPr txBox="1"/>
+          <p:nvPr/>
+        </p:nvSpPr>
+        <p:spPr>
+          <a:xfrm>
+            <a:off x="6309360" y="1874519"/>
+            <a:ext cx="5120640" cy="365760"/>
+          </a:xfrm>
+          <a:prstGeom prst="rect">
+            <a:avLst/>
+          </a:prstGeom>
+          <a:noFill/>
+        </p:spPr>
+        <p:txBody>
+          <a:bodyPr wrap="square">
+            <a:spAutoFit/>
+          </a:bodyPr>
+          <a:lstStyle/>
+          <a:p>
+            <a:pPr algn="l">
+              <a:defRPr sz="1400" b="1">
+                <a:solidFill>
+                  <a:srgbClr val="2563EB"/>
+                </a:solidFill>
+              </a:defRPr>
+            </a:pPr>
+            <a:r>
+              <a:t>Martins Nwanu — Head of IT, Creditville Group</a:t>
+            </a:r>
+          </a:p>
+        </p:txBody>
+      </p:sp>
+      <p:sp>
+        <p:nvSpPr>
+          <p:cNvPr id="11" name="TextBox 10"/>
+          <p:cNvSpPr txBox="1"/>
+          <p:nvPr/>
+        </p:nvSpPr>
+        <p:spPr>
+          <a:xfrm>
+            <a:off x="6309360" y="2240280"/>
+            <a:ext cx="5120640" cy="3200400"/>
+          </a:xfrm>
+          <a:prstGeom prst="rect">
+            <a:avLst/>
+          </a:prstGeom>
+          <a:noFill/>
+        </p:spPr>
+        <p:txBody>
+          <a:bodyPr wrap="square">
+            <a:spAutoFit/>
+          </a:bodyPr>
+          <a:lstStyle/>
           <a:p>
             <a:pPr>
               <a:spcAft>
-                <a:spcPts val="684"/>
+                <a:spcPts val="603"/>
               </a:spcAft>
-              <a:defRPr sz="1700">
+              <a:defRPr sz="1500">
                 <a:solidFill>
                   <a:srgbClr val="111827"/>
                 </a:solidFill>
               </a:defRPr>
             </a:pPr>
             <a:r>
-              <a:t>Portfolio of shipped full-stack systems: NorthBridge, Kairos, ProofSource, Autonix</a:t>
-            </a:r>
-          </a:p>
-        </p:txBody>
-      </p:sp>
-      <p:sp>
-        <p:nvSpPr>
-          <p:cNvPr id="9" name="TextBox 8"/>
+              <a:t>11-engineer leadership; core banking platform delivery</a:t>
+            </a:r>
+          </a:p>
+          <a:p>
+            <a:pPr>
+              <a:spcAft>
+                <a:spcPts val="603"/>
+              </a:spcAft>
+              <a:defRPr sz="1500">
+                <a:solidFill>
+                  <a:srgbClr val="111827"/>
+                </a:solidFill>
+              </a:defRPr>
+            </a:pPr>
+            <a:r>
+              <a:t>C Money 30K → 100K+ users; in-house mobile rebuild</a:t>
+            </a:r>
+          </a:p>
+          <a:p>
+            <a:pPr>
+              <a:spcAft>
+                <a:spcPts val="603"/>
+              </a:spcAft>
+              <a:defRPr sz="1500">
+                <a:solidFill>
+                  <a:srgbClr val="111827"/>
+                </a:solidFill>
+              </a:defRPr>
+            </a:pPr>
+            <a:r>
+              <a:t>Loan ops scaled to ₦800M–₦1B/month disbursements</a:t>
+            </a:r>
+          </a:p>
+          <a:p>
+            <a:pPr>
+              <a:spcAft>
+                <a:spcPts val="603"/>
+              </a:spcAft>
+              <a:defRPr sz="1500">
+                <a:solidFill>
+                  <a:srgbClr val="111827"/>
+                </a:solidFill>
+              </a:defRPr>
+            </a:pPr>
+            <a:r>
+              <a:t>Credara: production API, workspace UX, deploy discipline</a:t>
+            </a:r>
+          </a:p>
+        </p:txBody>
+      </p:sp>
+      <p:sp>
+        <p:nvSpPr>
+          <p:cNvPr id="12" name="Rectangle 11"/>
+          <p:cNvSpPr/>
+          <p:nvPr/>
+        </p:nvSpPr>
+        <p:spPr>
+          <a:xfrm>
+            <a:off x="6080760" y="1783080"/>
+            <a:ext cx="45720" cy="3840480"/>
+          </a:xfrm>
+          <a:prstGeom prst="rect">
+            <a:avLst/>
+          </a:prstGeom>
+          <a:solidFill>
+            <a:srgbClr val="E7EAF1"/>
+          </a:solidFill>
+          <a:ln>
+            <a:noFill/>
+          </a:ln>
+        </p:spPr>
+        <p:style>
+          <a:lnRef idx="1">
+            <a:schemeClr val="accent1"/>
+          </a:lnRef>
+          <a:fillRef idx="3">
+            <a:schemeClr val="accent1"/>
+          </a:fillRef>
+          <a:effectRef idx="2">
+            <a:schemeClr val="accent1"/>
+          </a:effectRef>
+          <a:fontRef idx="minor">
+            <a:schemeClr val="lt1"/>
+          </a:fontRef>
+        </p:style>
+        <p:txBody>
+          <a:bodyPr rtlCol="0" anchor="ctr"/>
+          <a:lstStyle/>
+          <a:p>
+            <a:pPr algn="ctr"/>
+          </a:p>
+        </p:txBody>
+      </p:sp>
+      <p:sp>
+        <p:nvSpPr>
+          <p:cNvPr id="13" name="TextBox 12"/>
           <p:cNvSpPr txBox="1"/>
           <p:nvPr/>
         </p:nvSpPr>

</xml_diff>